<commit_message>
chore: more documentation of Eclipse interface
</commit_message>
<xml_diff>
--- a/doc/SKM_EclipseModel-documentation.pptx
+++ b/doc/SKM_EclipseModel-documentation.pptx
@@ -761,6 +761,580 @@
     <p:extLst>
       <p:ext uri="{BB962C8B-B14F-4D97-AF65-F5344CB8AC3E}">
         <p14:creationId xmlns:p14="http://schemas.microsoft.com/office/powerpoint/2010/main" val="1188849660"/>
+      </p:ext>
+    </p:extLst>
+  </p:cSld>
+  <p:clrMapOvr>
+    <a:masterClrMapping/>
+  </p:clrMapOvr>
+</p:notes>
+</file>
+
+<file path=ppt/notesSlides/notesSlide2.xml><?xml version="1.0" encoding="utf-8"?>
+<p:notes xmlns:a="http://schemas.openxmlformats.org/drawingml/2006/main" xmlns:r="http://schemas.openxmlformats.org/officeDocument/2006/relationships" xmlns:p="http://schemas.openxmlformats.org/presentationml/2006/main">
+  <p:cSld>
+    <p:spTree>
+      <p:nvGrpSpPr>
+        <p:cNvPr id="1" name=""/>
+        <p:cNvGrpSpPr/>
+        <p:nvPr/>
+      </p:nvGrpSpPr>
+      <p:grpSpPr>
+        <a:xfrm>
+          <a:off x="0" y="0"/>
+          <a:ext cx="0" cy="0"/>
+          <a:chOff x="0" y="0"/>
+          <a:chExt cx="0" cy="0"/>
+        </a:xfrm>
+      </p:grpSpPr>
+      <p:sp>
+        <p:nvSpPr>
+          <p:cNvPr id="2" name="Slide Image Placeholder 1"/>
+          <p:cNvSpPr>
+            <a:spLocks noGrp="1" noRot="1" noChangeAspect="1"/>
+          </p:cNvSpPr>
+          <p:nvPr>
+            <p:ph type="sldImg"/>
+          </p:nvPr>
+        </p:nvSpPr>
+        <p:spPr/>
+      </p:sp>
+      <p:sp>
+        <p:nvSpPr>
+          <p:cNvPr id="3" name="Notes Placeholder 2"/>
+          <p:cNvSpPr>
+            <a:spLocks noGrp="1"/>
+          </p:cNvSpPr>
+          <p:nvPr>
+            <p:ph type="body" idx="1"/>
+          </p:nvPr>
+        </p:nvSpPr>
+        <p:spPr/>
+        <p:txBody>
+          <a:bodyPr/>
+          <a:lstStyle/>
+          <a:p>
+            <a:r>
+              <a:rPr lang="en-US" dirty="0" smtClean="0"/>
+              <a:t>COORD – grid</a:t>
+            </a:r>
+            <a:r>
+              <a:rPr lang="en-US" baseline="0" dirty="0" smtClean="0"/>
+              <a:t> top to bottom lines which become the pillars and are later subdivided by the cell corners </a:t>
+            </a:r>
+            <a:r>
+              <a:rPr lang="en-US" baseline="0" smtClean="0"/>
+              <a:t>specified in ZCORN.</a:t>
+            </a:r>
+            <a:endParaRPr lang="en-US" dirty="0" smtClean="0"/>
+          </a:p>
+          <a:p>
+            <a:pPr marL="0" marR="0" indent="0" algn="l" defTabSz="914400" rtl="0" eaLnBrk="1" fontAlgn="auto" latinLnBrk="0" hangingPunct="1">
+              <a:lnSpc>
+                <a:spcPct val="100000"/>
+              </a:lnSpc>
+              <a:spcBef>
+                <a:spcPts val="0"/>
+              </a:spcBef>
+              <a:spcAft>
+                <a:spcPts val="0"/>
+              </a:spcAft>
+              <a:buClrTx/>
+              <a:buSzTx/>
+              <a:buFontTx/>
+              <a:buNone/>
+              <a:tabLst/>
+              <a:defRPr/>
+            </a:pPr>
+            <a:r>
+              <a:rPr lang="en-US" sz="1200" kern="1200" dirty="0" smtClean="0">
+                <a:solidFill>
+                  <a:schemeClr val="tx1"/>
+                </a:solidFill>
+                <a:effectLst/>
+                <a:latin typeface="+mn-lt"/>
+                <a:ea typeface="+mn-ea"/>
+                <a:cs typeface="+mn-cs"/>
+              </a:rPr>
+              <a:t>“book order”, line after line until a page has been read, then the next page until all data has been read. I.e. First the top layer (</a:t>
+            </a:r>
+            <a:r>
+              <a:rPr lang="en-US" sz="1200" i="1" kern="1200" dirty="0" smtClean="0">
+                <a:solidFill>
+                  <a:schemeClr val="tx1"/>
+                </a:solidFill>
+                <a:effectLst/>
+                <a:latin typeface="+mn-lt"/>
+                <a:ea typeface="+mn-ea"/>
+                <a:cs typeface="+mn-cs"/>
+              </a:rPr>
+              <a:t>K=1</a:t>
+            </a:r>
+            <a:r>
+              <a:rPr lang="en-US" sz="1200" kern="1200" dirty="0" smtClean="0">
+                <a:solidFill>
+                  <a:schemeClr val="tx1"/>
+                </a:solidFill>
+                <a:effectLst/>
+                <a:latin typeface="+mn-lt"/>
+                <a:ea typeface="+mn-ea"/>
+                <a:cs typeface="+mn-cs"/>
+              </a:rPr>
+              <a:t>) is read, line by line (begin with </a:t>
+            </a:r>
+            <a:r>
+              <a:rPr lang="en-US" sz="1200" i="1" kern="1200" dirty="0" smtClean="0">
+                <a:solidFill>
+                  <a:schemeClr val="tx1"/>
+                </a:solidFill>
+                <a:effectLst/>
+                <a:latin typeface="+mn-lt"/>
+                <a:ea typeface="+mn-ea"/>
+                <a:cs typeface="+mn-cs"/>
+              </a:rPr>
+              <a:t>J=1</a:t>
+            </a:r>
+            <a:r>
+              <a:rPr lang="en-US" sz="1200" kern="1200" dirty="0" smtClean="0">
+                <a:solidFill>
+                  <a:schemeClr val="tx1"/>
+                </a:solidFill>
+                <a:effectLst/>
+                <a:latin typeface="+mn-lt"/>
+                <a:ea typeface="+mn-ea"/>
+                <a:cs typeface="+mn-cs"/>
+              </a:rPr>
+              <a:t>, read </a:t>
+            </a:r>
+            <a:r>
+              <a:rPr lang="en-US" sz="1200" i="1" kern="1200" dirty="0" smtClean="0">
+                <a:solidFill>
+                  <a:schemeClr val="tx1"/>
+                </a:solidFill>
+                <a:effectLst/>
+                <a:latin typeface="+mn-lt"/>
+                <a:ea typeface="+mn-ea"/>
+                <a:cs typeface="+mn-cs"/>
+              </a:rPr>
+              <a:t>I=1,...,NX</a:t>
+            </a:r>
+            <a:r>
+              <a:rPr lang="en-US" sz="1200" kern="1200" dirty="0" smtClean="0">
+                <a:solidFill>
+                  <a:schemeClr val="tx1"/>
+                </a:solidFill>
+                <a:effectLst/>
+                <a:latin typeface="+mn-lt"/>
+                <a:ea typeface="+mn-ea"/>
+                <a:cs typeface="+mn-cs"/>
+              </a:rPr>
+              <a:t>, then </a:t>
+            </a:r>
+            <a:r>
+              <a:rPr lang="en-US" sz="1200" i="1" kern="1200" dirty="0" smtClean="0">
+                <a:solidFill>
+                  <a:schemeClr val="tx1"/>
+                </a:solidFill>
+                <a:effectLst/>
+                <a:latin typeface="+mn-lt"/>
+                <a:ea typeface="+mn-ea"/>
+                <a:cs typeface="+mn-cs"/>
+              </a:rPr>
+              <a:t>J=2</a:t>
+            </a:r>
+            <a:r>
+              <a:rPr lang="en-US" sz="1200" kern="1200" dirty="0" smtClean="0">
+                <a:solidFill>
+                  <a:schemeClr val="tx1"/>
+                </a:solidFill>
+                <a:effectLst/>
+                <a:latin typeface="+mn-lt"/>
+                <a:ea typeface="+mn-ea"/>
+                <a:cs typeface="+mn-cs"/>
+              </a:rPr>
+              <a:t>, etc.) Then repeat for </a:t>
+            </a:r>
+            <a:r>
+              <a:rPr lang="en-US" sz="1200" i="1" kern="1200" dirty="0" smtClean="0">
+                <a:solidFill>
+                  <a:schemeClr val="tx1"/>
+                </a:solidFill>
+                <a:effectLst/>
+                <a:latin typeface="+mn-lt"/>
+                <a:ea typeface="+mn-ea"/>
+                <a:cs typeface="+mn-cs"/>
+              </a:rPr>
+              <a:t>K=2,...,NZ</a:t>
+            </a:r>
+            <a:r>
+              <a:rPr lang="en-US" sz="1200" kern="1200" dirty="0" smtClean="0">
+                <a:solidFill>
+                  <a:schemeClr val="tx1"/>
+                </a:solidFill>
+                <a:effectLst/>
+                <a:latin typeface="+mn-lt"/>
+                <a:ea typeface="+mn-ea"/>
+                <a:cs typeface="+mn-cs"/>
+              </a:rPr>
+              <a:t>.</a:t>
+            </a:r>
+          </a:p>
+          <a:p>
+            <a:pPr marL="0" marR="0" indent="0" algn="l" defTabSz="914400" rtl="0" eaLnBrk="1" fontAlgn="auto" latinLnBrk="0" hangingPunct="1">
+              <a:lnSpc>
+                <a:spcPct val="100000"/>
+              </a:lnSpc>
+              <a:spcBef>
+                <a:spcPts val="0"/>
+              </a:spcBef>
+              <a:spcAft>
+                <a:spcPts val="0"/>
+              </a:spcAft>
+              <a:buClrTx/>
+              <a:buSzTx/>
+              <a:buFontTx/>
+              <a:buNone/>
+              <a:tabLst/>
+              <a:defRPr/>
+            </a:pPr>
+            <a:endParaRPr lang="en-US" sz="1200" kern="1200" dirty="0" smtClean="0">
+              <a:solidFill>
+                <a:schemeClr val="tx1"/>
+              </a:solidFill>
+              <a:effectLst/>
+              <a:latin typeface="+mn-lt"/>
+              <a:ea typeface="+mn-ea"/>
+              <a:cs typeface="+mn-cs"/>
+            </a:endParaRPr>
+          </a:p>
+          <a:p>
+            <a:pPr marL="0" marR="0" indent="0" algn="l" defTabSz="914400" rtl="0" eaLnBrk="1" fontAlgn="auto" latinLnBrk="0" hangingPunct="1">
+              <a:lnSpc>
+                <a:spcPct val="100000"/>
+              </a:lnSpc>
+              <a:spcBef>
+                <a:spcPts val="0"/>
+              </a:spcBef>
+              <a:spcAft>
+                <a:spcPts val="0"/>
+              </a:spcAft>
+              <a:buClrTx/>
+              <a:buSzTx/>
+              <a:buFontTx/>
+              <a:buNone/>
+              <a:tabLst/>
+              <a:defRPr/>
+            </a:pPr>
+            <a:r>
+              <a:rPr lang="en-US" sz="1200" kern="1200" dirty="0" smtClean="0">
+                <a:solidFill>
+                  <a:schemeClr val="tx1"/>
+                </a:solidFill>
+                <a:effectLst/>
+                <a:latin typeface="+mn-lt"/>
+                <a:ea typeface="+mn-ea"/>
+                <a:cs typeface="+mn-cs"/>
+              </a:rPr>
+              <a:t>Example</a:t>
+            </a:r>
+          </a:p>
+          <a:p>
+            <a:r>
+              <a:rPr lang="en-US" sz="1200" kern="1200" dirty="0" smtClean="0">
+                <a:solidFill>
+                  <a:schemeClr val="tx1"/>
+                </a:solidFill>
+                <a:effectLst/>
+                <a:latin typeface="+mn-lt"/>
+                <a:ea typeface="+mn-ea"/>
+                <a:cs typeface="+mn-cs"/>
+              </a:rPr>
+              <a:t>COORD </a:t>
+            </a:r>
+            <a:endParaRPr lang="en-US" dirty="0" smtClean="0"/>
+          </a:p>
+          <a:p>
+            <a:r>
+              <a:rPr lang="en-US" sz="1200" i="1" kern="1200" dirty="0" smtClean="0">
+                <a:solidFill>
+                  <a:schemeClr val="tx1"/>
+                </a:solidFill>
+                <a:effectLst/>
+                <a:latin typeface="+mn-lt"/>
+                <a:ea typeface="+mn-ea"/>
+                <a:cs typeface="+mn-cs"/>
+              </a:rPr>
+              <a:t>x(1,1)TOP y(1,1)TOP z(1,1)TOP x(1,1)BTM y(1,1)BTM x(2,1)TOP y(2,1)TOP z(2,1)TOP x(2,1)BTM y(2,1)BTM x(3,1)TOP y(3,1)TOP z(3,1)TOP x(3,1)BTM y31,1)BTM . </a:t>
+            </a:r>
+            <a:endParaRPr lang="en-US" dirty="0" smtClean="0"/>
+          </a:p>
+          <a:p>
+            <a:r>
+              <a:rPr lang="en-US" sz="1200" i="1" kern="1200" dirty="0" smtClean="0">
+                <a:solidFill>
+                  <a:schemeClr val="tx1"/>
+                </a:solidFill>
+                <a:effectLst/>
+                <a:latin typeface="+mn-lt"/>
+                <a:ea typeface="+mn-ea"/>
+                <a:cs typeface="+mn-cs"/>
+              </a:rPr>
+              <a:t>.</a:t>
+            </a:r>
+            <a:br>
+              <a:rPr lang="en-US" sz="1200" i="1" kern="1200" dirty="0" smtClean="0">
+                <a:solidFill>
+                  <a:schemeClr val="tx1"/>
+                </a:solidFill>
+                <a:effectLst/>
+                <a:latin typeface="+mn-lt"/>
+                <a:ea typeface="+mn-ea"/>
+                <a:cs typeface="+mn-cs"/>
+              </a:rPr>
+            </a:br>
+            <a:r>
+              <a:rPr lang="en-US" sz="1200" i="1" kern="1200" dirty="0" smtClean="0">
+                <a:solidFill>
+                  <a:schemeClr val="tx1"/>
+                </a:solidFill>
+                <a:effectLst/>
+                <a:latin typeface="+mn-lt"/>
+                <a:ea typeface="+mn-ea"/>
+                <a:cs typeface="+mn-cs"/>
+              </a:rPr>
+              <a:t>.x(NX+1,NY+1)TOP y(NX+1,NY+1)TOP z(NX+1,NY+1)TOP x(NX+1,NY+1)BTM y(NX+1,NY+1)BTM z(NX+1,NY+1)BTM </a:t>
+            </a:r>
+            <a:endParaRPr lang="en-US" dirty="0" smtClean="0"/>
+          </a:p>
+          <a:p>
+            <a:r>
+              <a:rPr lang="en-US" sz="1200" i="1" kern="1200" dirty="0" smtClean="0">
+                <a:solidFill>
+                  <a:schemeClr val="tx1"/>
+                </a:solidFill>
+                <a:effectLst/>
+                <a:latin typeface="+mn-lt"/>
+                <a:ea typeface="+mn-ea"/>
+                <a:cs typeface="+mn-cs"/>
+              </a:rPr>
+              <a:t>z(1,1)BTM z(2,1)BTM z(3,1)BTM </a:t>
+            </a:r>
+            <a:endParaRPr lang="en-US" dirty="0" smtClean="0"/>
+          </a:p>
+          <a:p>
+            <a:pPr marL="0" marR="0" indent="0" algn="l" defTabSz="914400" rtl="0" eaLnBrk="1" fontAlgn="auto" latinLnBrk="0" hangingPunct="1">
+              <a:lnSpc>
+                <a:spcPct val="100000"/>
+              </a:lnSpc>
+              <a:spcBef>
+                <a:spcPts val="0"/>
+              </a:spcBef>
+              <a:spcAft>
+                <a:spcPts val="0"/>
+              </a:spcAft>
+              <a:buClrTx/>
+              <a:buSzTx/>
+              <a:buFontTx/>
+              <a:buNone/>
+              <a:tabLst/>
+              <a:defRPr/>
+            </a:pPr>
+            <a:endParaRPr lang="en-US" sz="1200" kern="1200" dirty="0" smtClean="0">
+              <a:solidFill>
+                <a:schemeClr val="tx1"/>
+              </a:solidFill>
+              <a:effectLst/>
+              <a:latin typeface="+mn-lt"/>
+              <a:ea typeface="+mn-ea"/>
+              <a:cs typeface="+mn-cs"/>
+            </a:endParaRPr>
+          </a:p>
+          <a:p>
+            <a:pPr marL="0" marR="0" indent="0" algn="l" defTabSz="914400" rtl="0" eaLnBrk="1" fontAlgn="auto" latinLnBrk="0" hangingPunct="1">
+              <a:lnSpc>
+                <a:spcPct val="100000"/>
+              </a:lnSpc>
+              <a:spcBef>
+                <a:spcPts val="0"/>
+              </a:spcBef>
+              <a:spcAft>
+                <a:spcPts val="0"/>
+              </a:spcAft>
+              <a:buClrTx/>
+              <a:buSzTx/>
+              <a:buFontTx/>
+              <a:buNone/>
+              <a:tabLst/>
+              <a:defRPr/>
+            </a:pPr>
+            <a:r>
+              <a:rPr lang="en-US" sz="1200" kern="1200" dirty="0" smtClean="0">
+                <a:solidFill>
+                  <a:schemeClr val="tx1"/>
+                </a:solidFill>
+                <a:effectLst/>
+                <a:latin typeface="+mn-lt"/>
+                <a:ea typeface="+mn-ea"/>
+                <a:cs typeface="+mn-cs"/>
+              </a:rPr>
+              <a:t> </a:t>
+            </a:r>
+            <a:endParaRPr lang="en-US" dirty="0" smtClean="0"/>
+          </a:p>
+          <a:p>
+            <a:r>
+              <a:rPr lang="en-US" dirty="0" smtClean="0"/>
+              <a:t> ZCORN</a:t>
+            </a:r>
+          </a:p>
+          <a:p>
+            <a:r>
+              <a:rPr lang="en-US" dirty="0" smtClean="0"/>
+              <a:t>vertical segmentation</a:t>
+            </a:r>
+            <a:r>
+              <a:rPr lang="en-US" baseline="0" dirty="0" smtClean="0"/>
+              <a:t> of the pillars</a:t>
+            </a:r>
+            <a:endParaRPr lang="en-US" dirty="0" smtClean="0"/>
+          </a:p>
+          <a:p>
+            <a:endParaRPr lang="en-US" dirty="0" smtClean="0"/>
+          </a:p>
+          <a:p>
+            <a:r>
+              <a:rPr lang="en-US" dirty="0" smtClean="0"/>
+              <a:t>0. read the grid,</a:t>
+            </a:r>
+            <a:r>
+              <a:rPr lang="en-US" baseline="0" dirty="0" smtClean="0"/>
+              <a:t> there will be an </a:t>
+            </a:r>
+            <a:r>
+              <a:rPr lang="en-US" baseline="0" dirty="0" err="1" smtClean="0"/>
+              <a:t>i,j,k</a:t>
+            </a:r>
+            <a:r>
+              <a:rPr lang="en-US" baseline="0" dirty="0" smtClean="0"/>
+              <a:t>, for each point and a point location corresponding to it. However, some points (in dead cells) coincide, which can be collapsed into single nodes.</a:t>
+            </a:r>
+          </a:p>
+          <a:p>
+            <a:r>
+              <a:rPr lang="en-US" baseline="0" dirty="0" smtClean="0"/>
+              <a:t>data structure:  key(</a:t>
+            </a:r>
+            <a:r>
+              <a:rPr lang="en-US" baseline="0" dirty="0" err="1" smtClean="0"/>
+              <a:t>I,j,k</a:t>
+            </a:r>
+            <a:r>
+              <a:rPr lang="en-US" baseline="0" dirty="0" smtClean="0"/>
+              <a:t>), value uniquely numbered point (pair(</a:t>
+            </a:r>
+            <a:r>
+              <a:rPr lang="en-US" baseline="0" dirty="0" err="1" smtClean="0"/>
+              <a:t>point,idx</a:t>
+            </a:r>
+            <a:r>
+              <a:rPr lang="en-US" baseline="0" dirty="0" smtClean="0"/>
+              <a:t>)). This means that different </a:t>
+            </a:r>
+            <a:r>
+              <a:rPr lang="en-US" baseline="0" dirty="0" err="1" smtClean="0"/>
+              <a:t>I,j,k’s</a:t>
+            </a:r>
+            <a:r>
+              <a:rPr lang="en-US" baseline="0" dirty="0" smtClean="0"/>
+              <a:t> point to the same point and id.</a:t>
+            </a:r>
+            <a:endParaRPr lang="en-US" dirty="0" smtClean="0"/>
+          </a:p>
+          <a:p>
+            <a:endParaRPr lang="en-US" dirty="0" smtClean="0"/>
+          </a:p>
+          <a:p>
+            <a:r>
+              <a:rPr lang="en-US" b="1" dirty="0" smtClean="0"/>
+              <a:t>Grid construction</a:t>
+            </a:r>
+            <a:r>
+              <a:rPr lang="en-US" b="1" baseline="0" dirty="0" smtClean="0"/>
+              <a:t> algorithm (starting with the pillars with beads)</a:t>
+            </a:r>
+            <a:endParaRPr lang="en-US" b="1" dirty="0" smtClean="0"/>
+          </a:p>
+          <a:p>
+            <a:r>
+              <a:rPr lang="en-US" dirty="0" smtClean="0"/>
+              <a:t>1. find the locations</a:t>
+            </a:r>
+            <a:r>
+              <a:rPr lang="en-US" baseline="0" dirty="0" smtClean="0"/>
+              <a:t> (in CSMP coordinate space) of the corner-points of the Eclipse grid. Number these points. Currently, these are stored in the Pillar 2D array.</a:t>
+            </a:r>
+            <a:endParaRPr lang="en-US" dirty="0" smtClean="0"/>
+          </a:p>
+          <a:p>
+            <a:r>
+              <a:rPr lang="en-US" dirty="0" smtClean="0"/>
+              <a:t>2. w</a:t>
+            </a:r>
+            <a:r>
+              <a:rPr lang="en-US" baseline="0" dirty="0" smtClean="0"/>
+              <a:t>alk over the corner-point grid (via pillars) mapping out which points make up the cells</a:t>
+            </a:r>
+          </a:p>
+          <a:p>
+            <a:r>
+              <a:rPr lang="en-US" baseline="0" dirty="0" smtClean="0"/>
+              <a:t>3. create a unique numbering for all points</a:t>
+            </a:r>
+          </a:p>
+          <a:p>
+            <a:r>
+              <a:rPr lang="en-US" baseline="0" dirty="0" smtClean="0"/>
+              <a:t>4. create a </a:t>
+            </a:r>
+            <a:r>
+              <a:rPr lang="en-US" baseline="0" dirty="0" err="1" smtClean="0"/>
+              <a:t>plist</a:t>
+            </a:r>
+            <a:r>
+              <a:rPr lang="en-US" baseline="0" dirty="0" smtClean="0"/>
+              <a:t> from this unique numbering</a:t>
+            </a:r>
+            <a:endParaRPr lang="en-US" dirty="0"/>
+          </a:p>
+        </p:txBody>
+      </p:sp>
+      <p:sp>
+        <p:nvSpPr>
+          <p:cNvPr id="4" name="Slide Number Placeholder 3"/>
+          <p:cNvSpPr>
+            <a:spLocks noGrp="1"/>
+          </p:cNvSpPr>
+          <p:nvPr>
+            <p:ph type="sldNum" sz="quarter" idx="10"/>
+          </p:nvPr>
+        </p:nvSpPr>
+        <p:spPr/>
+        <p:txBody>
+          <a:bodyPr/>
+          <a:lstStyle/>
+          <a:p>
+            <a:fld id="{17BE335B-F28A-CF43-9B42-58B2A7087868}" type="slidenum">
+              <a:rPr lang="en-US" smtClean="0"/>
+              <a:t>3</a:t>
+            </a:fld>
+            <a:endParaRPr lang="en-US"/>
+          </a:p>
+        </p:txBody>
+      </p:sp>
+    </p:spTree>
+    <p:extLst>
+      <p:ext uri="{BB962C8B-B14F-4D97-AF65-F5344CB8AC3E}">
+        <p14:creationId xmlns:p14="http://schemas.microsoft.com/office/powerpoint/2010/main" val="3379046957"/>
       </p:ext>
     </p:extLst>
   </p:cSld>
@@ -7270,6 +7844,102 @@
           <a:bodyPr/>
           <a:lstStyle/>
           <a:p>
+            <a:pPr marL="0" indent="0">
+              <a:buNone/>
+            </a:pPr>
+            <a:r>
+              <a:rPr lang="en-US" sz="1400" i="1" dirty="0" smtClean="0">
+                <a:latin typeface="Arial"/>
+                <a:cs typeface="Arial"/>
+              </a:rPr>
+              <a:t>Coming from </a:t>
+            </a:r>
+            <a:r>
+              <a:rPr lang="en-US" sz="1400" i="1" dirty="0" err="1" smtClean="0">
+                <a:latin typeface="Arial"/>
+                <a:cs typeface="Arial"/>
+              </a:rPr>
+              <a:t>BuildModel</a:t>
+            </a:r>
+            <a:r>
+              <a:rPr lang="en-US" sz="1400" i="1" dirty="0" smtClean="0">
+                <a:latin typeface="Arial"/>
+                <a:cs typeface="Arial"/>
+              </a:rPr>
+              <a:t>()-&gt;</a:t>
+            </a:r>
+            <a:r>
+              <a:rPr lang="en-US" sz="1400" i="1" dirty="0" err="1" smtClean="0">
+                <a:latin typeface="Arial"/>
+                <a:cs typeface="Arial"/>
+              </a:rPr>
+              <a:t>ReadFile</a:t>
+            </a:r>
+            <a:r>
+              <a:rPr lang="en-US" sz="1400" i="1" dirty="0" smtClean="0">
+                <a:latin typeface="Arial"/>
+                <a:cs typeface="Arial"/>
+              </a:rPr>
+              <a:t>()-&gt;</a:t>
+            </a:r>
+            <a:r>
+              <a:rPr lang="en-US" sz="1400" i="1" dirty="0" err="1" smtClean="0">
+                <a:latin typeface="Arial"/>
+                <a:cs typeface="Arial"/>
+              </a:rPr>
+              <a:t>ReadFile</a:t>
+            </a:r>
+            <a:r>
+              <a:rPr lang="en-US" sz="1400" i="1" dirty="0" smtClean="0">
+                <a:latin typeface="Arial"/>
+                <a:cs typeface="Arial"/>
+              </a:rPr>
+              <a:t>() – </a:t>
+            </a:r>
+            <a:r>
+              <a:rPr lang="en-US" sz="1400" i="1" dirty="0" err="1" smtClean="0">
+                <a:latin typeface="Arial"/>
+                <a:cs typeface="Arial"/>
+              </a:rPr>
+              <a:t>EclipseInterface</a:t>
+            </a:r>
+            <a:r>
+              <a:rPr lang="en-US" sz="1400" i="1" dirty="0" smtClean="0">
+                <a:latin typeface="Arial"/>
+                <a:cs typeface="Arial"/>
+              </a:rPr>
+              <a:t>::</a:t>
+            </a:r>
+            <a:r>
+              <a:rPr lang="en-US" sz="1400" i="1" dirty="0" err="1" smtClean="0">
+                <a:latin typeface="Arial"/>
+                <a:cs typeface="Arial"/>
+              </a:rPr>
+              <a:t>ReadBlock</a:t>
+            </a:r>
+            <a:r>
+              <a:rPr lang="en-US" sz="1400" i="1" dirty="0" smtClean="0">
+                <a:latin typeface="Arial"/>
+                <a:cs typeface="Arial"/>
+              </a:rPr>
+              <a:t>() – </a:t>
+            </a:r>
+            <a:r>
+              <a:rPr lang="en-US" sz="1400" i="1" dirty="0" err="1" smtClean="0">
+                <a:latin typeface="Arial"/>
+                <a:cs typeface="Arial"/>
+              </a:rPr>
+              <a:t>Read_COORD</a:t>
+            </a:r>
+            <a:r>
+              <a:rPr lang="en-US" sz="1400" i="1" dirty="0" smtClean="0">
+                <a:latin typeface="Arial"/>
+                <a:cs typeface="Arial"/>
+              </a:rPr>
+              <a:t> etc.  – stuffing the data into different objects.</a:t>
+            </a:r>
+          </a:p>
+          <a:p>
             <a:r>
               <a:rPr lang="en-US" sz="1400" dirty="0" err="1" smtClean="0">
                 <a:latin typeface="Arial"/>
@@ -7298,7 +7968,7 @@
                 <a:latin typeface="Arial"/>
                 <a:cs typeface="Arial"/>
               </a:rPr>
-              <a:t>()</a:t>
+              <a:t>() – seems to calculate which grid-points will define each FE cell</a:t>
             </a:r>
           </a:p>
           <a:p>
@@ -7319,6 +7989,30 @@
           </a:p>
         </p:txBody>
       </p:sp>
+      <p:pic>
+        <p:nvPicPr>
+          <p:cNvPr id="4" name="Picture 3"/>
+          <p:cNvPicPr>
+            <a:picLocks noChangeAspect="1"/>
+          </p:cNvPicPr>
+          <p:nvPr/>
+        </p:nvPicPr>
+        <p:blipFill>
+          <a:blip r:embed="rId3"/>
+          <a:stretch>
+            <a:fillRect/>
+          </a:stretch>
+        </p:blipFill>
+        <p:spPr>
+          <a:xfrm>
+            <a:off x="7672886" y="2505780"/>
+            <a:ext cx="4133608" cy="3112202"/>
+          </a:xfrm>
+          <a:prstGeom prst="rect">
+            <a:avLst/>
+          </a:prstGeom>
+        </p:spPr>
+      </p:pic>
     </p:spTree>
     <p:extLst>
       <p:ext uri="{BB962C8B-B14F-4D97-AF65-F5344CB8AC3E}">

</xml_diff>

<commit_message>
chore: some more fixes
</commit_message>
<xml_diff>
--- a/doc/SKM_EclipseModel-documentation.pptx
+++ b/doc/SKM_EclipseModel-documentation.pptx
@@ -194,7 +194,7 @@
           <a:p>
             <a:fld id="{63B4E1BC-3CD9-864F-BF79-7B44BEA57458}" type="datetimeFigureOut">
               <a:rPr lang="en-US" smtClean="0"/>
-              <a:t>19/04/18</a:t>
+              <a:t>23/04/18</a:t>
             </a:fld>
             <a:endParaRPr lang="en-US"/>
           </a:p>
@@ -684,6 +684,37 @@
               <a:buFontTx/>
               <a:buChar char="-"/>
             </a:pPr>
+            <a:r>
+              <a:rPr lang="en-US" baseline="0" dirty="0" smtClean="0"/>
+              <a:t>extend </a:t>
+            </a:r>
+            <a:r>
+              <a:rPr lang="en-US" baseline="0" dirty="0" err="1" smtClean="0"/>
+              <a:t>EclipseWell</a:t>
+            </a:r>
+            <a:r>
+              <a:rPr lang="en-US" baseline="0" dirty="0" smtClean="0"/>
+              <a:t> (consisting of grid blocks to contain the </a:t>
+            </a:r>
+            <a:r>
+              <a:rPr lang="en-US" baseline="0" dirty="0" err="1" smtClean="0"/>
+              <a:t>Peaceman</a:t>
+            </a:r>
+            <a:r>
+              <a:rPr lang="en-US" baseline="0" dirty="0" smtClean="0"/>
+              <a:t> well model = realistic BHP from grid-block size vs. </a:t>
+            </a:r>
+            <a:r>
+              <a:rPr lang="en-US" baseline="0" smtClean="0"/>
+              <a:t>completion diameter)</a:t>
+            </a:r>
+            <a:endParaRPr lang="en-US" baseline="0" dirty="0" smtClean="0"/>
+          </a:p>
+          <a:p>
+            <a:pPr marL="171450" indent="-171450">
+              <a:buFontTx/>
+              <a:buChar char="-"/>
+            </a:pPr>
             <a:endParaRPr lang="en-US" baseline="0" dirty="0" smtClean="0"/>
           </a:p>
           <a:p>
@@ -820,11 +851,7 @@
             </a:r>
             <a:r>
               <a:rPr lang="en-US" baseline="0" dirty="0" smtClean="0"/>
-              <a:t> top to bottom lines which become the pillars and are later subdivided by the cell corners </a:t>
-            </a:r>
-            <a:r>
-              <a:rPr lang="en-US" baseline="0" smtClean="0"/>
-              <a:t>specified in ZCORN.</a:t>
+              <a:t> top to bottom lines which become the pillars and are later subdivided by the cell corners specified in ZCORN.</a:t>
             </a:r>
             <a:endParaRPr lang="en-US" dirty="0" smtClean="0"/>
           </a:p>
@@ -1366,7 +1393,7 @@
           <p:cNvPr id="2" name="Title 1">
             <a:extLst>
               <a:ext uri="{FF2B5EF4-FFF2-40B4-BE49-F238E27FC236}">
-                <a16:creationId xmlns:a16="http://schemas.microsoft.com/office/drawing/2014/main" xmlns="" id="{2F5B9EAF-F5C2-CC4F-A6D8-5E57AD5CD0A9}"/>
+                <a16:creationId xmlns="" xmlns:a16="http://schemas.microsoft.com/office/drawing/2014/main" id="{2F5B9EAF-F5C2-CC4F-A6D8-5E57AD5CD0A9}"/>
               </a:ext>
             </a:extLst>
           </p:cNvPr>
@@ -1403,7 +1430,7 @@
           <p:cNvPr id="3" name="Subtitle 2">
             <a:extLst>
               <a:ext uri="{FF2B5EF4-FFF2-40B4-BE49-F238E27FC236}">
-                <a16:creationId xmlns:a16="http://schemas.microsoft.com/office/drawing/2014/main" xmlns="" id="{991283FB-9E2F-0A42-9CF2-C5DE2B853334}"/>
+                <a16:creationId xmlns="" xmlns:a16="http://schemas.microsoft.com/office/drawing/2014/main" id="{991283FB-9E2F-0A42-9CF2-C5DE2B853334}"/>
               </a:ext>
             </a:extLst>
           </p:cNvPr>
@@ -1473,7 +1500,7 @@
           <p:cNvPr id="4" name="Date Placeholder 3">
             <a:extLst>
               <a:ext uri="{FF2B5EF4-FFF2-40B4-BE49-F238E27FC236}">
-                <a16:creationId xmlns:a16="http://schemas.microsoft.com/office/drawing/2014/main" xmlns="" id="{0D29A422-DB8D-124B-AF22-667131FC5343}"/>
+                <a16:creationId xmlns="" xmlns:a16="http://schemas.microsoft.com/office/drawing/2014/main" id="{0D29A422-DB8D-124B-AF22-667131FC5343}"/>
               </a:ext>
             </a:extLst>
           </p:cNvPr>
@@ -1491,7 +1518,7 @@
           <a:p>
             <a:fld id="{6BBF20CF-2588-EA45-96A5-9B2A2D83F5D1}" type="datetimeFigureOut">
               <a:rPr lang="en-US" smtClean="0"/>
-              <a:t>19/04/18</a:t>
+              <a:t>23/04/18</a:t>
             </a:fld>
             <a:endParaRPr lang="en-US"/>
           </a:p>
@@ -1502,7 +1529,7 @@
           <p:cNvPr id="5" name="Footer Placeholder 4">
             <a:extLst>
               <a:ext uri="{FF2B5EF4-FFF2-40B4-BE49-F238E27FC236}">
-                <a16:creationId xmlns:a16="http://schemas.microsoft.com/office/drawing/2014/main" xmlns="" id="{C3AADFF0-7462-4641-9F0C-AE5A02B8D133}"/>
+                <a16:creationId xmlns="" xmlns:a16="http://schemas.microsoft.com/office/drawing/2014/main" id="{C3AADFF0-7462-4641-9F0C-AE5A02B8D133}"/>
               </a:ext>
             </a:extLst>
           </p:cNvPr>
@@ -1527,7 +1554,7 @@
           <p:cNvPr id="6" name="Slide Number Placeholder 5">
             <a:extLst>
               <a:ext uri="{FF2B5EF4-FFF2-40B4-BE49-F238E27FC236}">
-                <a16:creationId xmlns:a16="http://schemas.microsoft.com/office/drawing/2014/main" xmlns="" id="{227A0EBA-04EC-F644-994E-5C46815D7008}"/>
+                <a16:creationId xmlns="" xmlns:a16="http://schemas.microsoft.com/office/drawing/2014/main" id="{227A0EBA-04EC-F644-994E-5C46815D7008}"/>
               </a:ext>
             </a:extLst>
           </p:cNvPr>
@@ -1586,7 +1613,7 @@
           <p:cNvPr id="2" name="Title 1">
             <a:extLst>
               <a:ext uri="{FF2B5EF4-FFF2-40B4-BE49-F238E27FC236}">
-                <a16:creationId xmlns:a16="http://schemas.microsoft.com/office/drawing/2014/main" xmlns="" id="{8E43F498-6D38-5544-8136-AEF471E9DC82}"/>
+                <a16:creationId xmlns="" xmlns:a16="http://schemas.microsoft.com/office/drawing/2014/main" id="{8E43F498-6D38-5544-8136-AEF471E9DC82}"/>
               </a:ext>
             </a:extLst>
           </p:cNvPr>
@@ -1614,7 +1641,7 @@
           <p:cNvPr id="3" name="Vertical Text Placeholder 2">
             <a:extLst>
               <a:ext uri="{FF2B5EF4-FFF2-40B4-BE49-F238E27FC236}">
-                <a16:creationId xmlns:a16="http://schemas.microsoft.com/office/drawing/2014/main" xmlns="" id="{9FC0007F-C11D-0046-9B43-E398F5D7CBE3}"/>
+                <a16:creationId xmlns="" xmlns:a16="http://schemas.microsoft.com/office/drawing/2014/main" id="{9FC0007F-C11D-0046-9B43-E398F5D7CBE3}"/>
               </a:ext>
             </a:extLst>
           </p:cNvPr>
@@ -1671,7 +1698,7 @@
           <p:cNvPr id="4" name="Date Placeholder 3">
             <a:extLst>
               <a:ext uri="{FF2B5EF4-FFF2-40B4-BE49-F238E27FC236}">
-                <a16:creationId xmlns:a16="http://schemas.microsoft.com/office/drawing/2014/main" xmlns="" id="{6941FE09-C07C-C242-AE2C-64C7FCFEA834}"/>
+                <a16:creationId xmlns="" xmlns:a16="http://schemas.microsoft.com/office/drawing/2014/main" id="{6941FE09-C07C-C242-AE2C-64C7FCFEA834}"/>
               </a:ext>
             </a:extLst>
           </p:cNvPr>
@@ -1689,7 +1716,7 @@
           <a:p>
             <a:fld id="{6BBF20CF-2588-EA45-96A5-9B2A2D83F5D1}" type="datetimeFigureOut">
               <a:rPr lang="en-US" smtClean="0"/>
-              <a:t>19/04/18</a:t>
+              <a:t>23/04/18</a:t>
             </a:fld>
             <a:endParaRPr lang="en-US"/>
           </a:p>
@@ -1700,7 +1727,7 @@
           <p:cNvPr id="5" name="Footer Placeholder 4">
             <a:extLst>
               <a:ext uri="{FF2B5EF4-FFF2-40B4-BE49-F238E27FC236}">
-                <a16:creationId xmlns:a16="http://schemas.microsoft.com/office/drawing/2014/main" xmlns="" id="{4BCA576F-3B5C-4C44-B77A-6E7279556EB0}"/>
+                <a16:creationId xmlns="" xmlns:a16="http://schemas.microsoft.com/office/drawing/2014/main" id="{4BCA576F-3B5C-4C44-B77A-6E7279556EB0}"/>
               </a:ext>
             </a:extLst>
           </p:cNvPr>
@@ -1725,7 +1752,7 @@
           <p:cNvPr id="6" name="Slide Number Placeholder 5">
             <a:extLst>
               <a:ext uri="{FF2B5EF4-FFF2-40B4-BE49-F238E27FC236}">
-                <a16:creationId xmlns:a16="http://schemas.microsoft.com/office/drawing/2014/main" xmlns="" id="{DCDEA7A1-8E53-284D-AD2C-51DBA23E2D99}"/>
+                <a16:creationId xmlns="" xmlns:a16="http://schemas.microsoft.com/office/drawing/2014/main" id="{DCDEA7A1-8E53-284D-AD2C-51DBA23E2D99}"/>
               </a:ext>
             </a:extLst>
           </p:cNvPr>
@@ -1784,7 +1811,7 @@
           <p:cNvPr id="2" name="Vertical Title 1">
             <a:extLst>
               <a:ext uri="{FF2B5EF4-FFF2-40B4-BE49-F238E27FC236}">
-                <a16:creationId xmlns:a16="http://schemas.microsoft.com/office/drawing/2014/main" xmlns="" id="{F58CDEB0-52DB-724B-BEF6-E6DD5F5BBAA9}"/>
+                <a16:creationId xmlns="" xmlns:a16="http://schemas.microsoft.com/office/drawing/2014/main" id="{F58CDEB0-52DB-724B-BEF6-E6DD5F5BBAA9}"/>
               </a:ext>
             </a:extLst>
           </p:cNvPr>
@@ -1817,7 +1844,7 @@
           <p:cNvPr id="3" name="Vertical Text Placeholder 2">
             <a:extLst>
               <a:ext uri="{FF2B5EF4-FFF2-40B4-BE49-F238E27FC236}">
-                <a16:creationId xmlns:a16="http://schemas.microsoft.com/office/drawing/2014/main" xmlns="" id="{5FA4CF4A-298E-EF4C-BDE7-2A0FBEFFB2B1}"/>
+                <a16:creationId xmlns="" xmlns:a16="http://schemas.microsoft.com/office/drawing/2014/main" id="{5FA4CF4A-298E-EF4C-BDE7-2A0FBEFFB2B1}"/>
               </a:ext>
             </a:extLst>
           </p:cNvPr>
@@ -1879,7 +1906,7 @@
           <p:cNvPr id="4" name="Date Placeholder 3">
             <a:extLst>
               <a:ext uri="{FF2B5EF4-FFF2-40B4-BE49-F238E27FC236}">
-                <a16:creationId xmlns:a16="http://schemas.microsoft.com/office/drawing/2014/main" xmlns="" id="{F10127C1-960F-8741-A88C-A08D865E395E}"/>
+                <a16:creationId xmlns="" xmlns:a16="http://schemas.microsoft.com/office/drawing/2014/main" id="{F10127C1-960F-8741-A88C-A08D865E395E}"/>
               </a:ext>
             </a:extLst>
           </p:cNvPr>
@@ -1897,7 +1924,7 @@
           <a:p>
             <a:fld id="{6BBF20CF-2588-EA45-96A5-9B2A2D83F5D1}" type="datetimeFigureOut">
               <a:rPr lang="en-US" smtClean="0"/>
-              <a:t>19/04/18</a:t>
+              <a:t>23/04/18</a:t>
             </a:fld>
             <a:endParaRPr lang="en-US"/>
           </a:p>
@@ -1908,7 +1935,7 @@
           <p:cNvPr id="5" name="Footer Placeholder 4">
             <a:extLst>
               <a:ext uri="{FF2B5EF4-FFF2-40B4-BE49-F238E27FC236}">
-                <a16:creationId xmlns:a16="http://schemas.microsoft.com/office/drawing/2014/main" xmlns="" id="{6AE0BEA5-D9A7-5848-859F-B8309DF668F5}"/>
+                <a16:creationId xmlns="" xmlns:a16="http://schemas.microsoft.com/office/drawing/2014/main" id="{6AE0BEA5-D9A7-5848-859F-B8309DF668F5}"/>
               </a:ext>
             </a:extLst>
           </p:cNvPr>
@@ -1933,7 +1960,7 @@
           <p:cNvPr id="6" name="Slide Number Placeholder 5">
             <a:extLst>
               <a:ext uri="{FF2B5EF4-FFF2-40B4-BE49-F238E27FC236}">
-                <a16:creationId xmlns:a16="http://schemas.microsoft.com/office/drawing/2014/main" xmlns="" id="{7EBAF9E2-5FE6-A64D-9337-C4F728E28133}"/>
+                <a16:creationId xmlns="" xmlns:a16="http://schemas.microsoft.com/office/drawing/2014/main" id="{7EBAF9E2-5FE6-A64D-9337-C4F728E28133}"/>
               </a:ext>
             </a:extLst>
           </p:cNvPr>
@@ -1992,7 +2019,7 @@
           <p:cNvPr id="2" name="Title 1">
             <a:extLst>
               <a:ext uri="{FF2B5EF4-FFF2-40B4-BE49-F238E27FC236}">
-                <a16:creationId xmlns:a16="http://schemas.microsoft.com/office/drawing/2014/main" xmlns="" id="{5201B2A0-7796-5746-9D1D-3370AA2E95AD}"/>
+                <a16:creationId xmlns="" xmlns:a16="http://schemas.microsoft.com/office/drawing/2014/main" id="{5201B2A0-7796-5746-9D1D-3370AA2E95AD}"/>
               </a:ext>
             </a:extLst>
           </p:cNvPr>
@@ -2020,7 +2047,7 @@
           <p:cNvPr id="3" name="Content Placeholder 2">
             <a:extLst>
               <a:ext uri="{FF2B5EF4-FFF2-40B4-BE49-F238E27FC236}">
-                <a16:creationId xmlns:a16="http://schemas.microsoft.com/office/drawing/2014/main" xmlns="" id="{7A012D8D-8E7D-334B-912E-EB74517572A4}"/>
+                <a16:creationId xmlns="" xmlns:a16="http://schemas.microsoft.com/office/drawing/2014/main" id="{7A012D8D-8E7D-334B-912E-EB74517572A4}"/>
               </a:ext>
             </a:extLst>
           </p:cNvPr>
@@ -2077,7 +2104,7 @@
           <p:cNvPr id="4" name="Date Placeholder 3">
             <a:extLst>
               <a:ext uri="{FF2B5EF4-FFF2-40B4-BE49-F238E27FC236}">
-                <a16:creationId xmlns:a16="http://schemas.microsoft.com/office/drawing/2014/main" xmlns="" id="{6B7DF5D5-C3AE-1642-9482-9061DC9AD044}"/>
+                <a16:creationId xmlns="" xmlns:a16="http://schemas.microsoft.com/office/drawing/2014/main" id="{6B7DF5D5-C3AE-1642-9482-9061DC9AD044}"/>
               </a:ext>
             </a:extLst>
           </p:cNvPr>
@@ -2095,7 +2122,7 @@
           <a:p>
             <a:fld id="{6BBF20CF-2588-EA45-96A5-9B2A2D83F5D1}" type="datetimeFigureOut">
               <a:rPr lang="en-US" smtClean="0"/>
-              <a:t>19/04/18</a:t>
+              <a:t>23/04/18</a:t>
             </a:fld>
             <a:endParaRPr lang="en-US"/>
           </a:p>
@@ -2106,7 +2133,7 @@
           <p:cNvPr id="5" name="Footer Placeholder 4">
             <a:extLst>
               <a:ext uri="{FF2B5EF4-FFF2-40B4-BE49-F238E27FC236}">
-                <a16:creationId xmlns:a16="http://schemas.microsoft.com/office/drawing/2014/main" xmlns="" id="{81F1EBAD-FBE6-A44C-9F1C-2A0EFCA3B0DF}"/>
+                <a16:creationId xmlns="" xmlns:a16="http://schemas.microsoft.com/office/drawing/2014/main" id="{81F1EBAD-FBE6-A44C-9F1C-2A0EFCA3B0DF}"/>
               </a:ext>
             </a:extLst>
           </p:cNvPr>
@@ -2131,7 +2158,7 @@
           <p:cNvPr id="6" name="Slide Number Placeholder 5">
             <a:extLst>
               <a:ext uri="{FF2B5EF4-FFF2-40B4-BE49-F238E27FC236}">
-                <a16:creationId xmlns:a16="http://schemas.microsoft.com/office/drawing/2014/main" xmlns="" id="{7A786D3D-E57F-8841-80ED-2A963A55A06B}"/>
+                <a16:creationId xmlns="" xmlns:a16="http://schemas.microsoft.com/office/drawing/2014/main" id="{7A786D3D-E57F-8841-80ED-2A963A55A06B}"/>
               </a:ext>
             </a:extLst>
           </p:cNvPr>
@@ -2190,7 +2217,7 @@
           <p:cNvPr id="2" name="Title 1">
             <a:extLst>
               <a:ext uri="{FF2B5EF4-FFF2-40B4-BE49-F238E27FC236}">
-                <a16:creationId xmlns:a16="http://schemas.microsoft.com/office/drawing/2014/main" xmlns="" id="{E7058B69-BEB8-324B-86E4-4983AC656F38}"/>
+                <a16:creationId xmlns="" xmlns:a16="http://schemas.microsoft.com/office/drawing/2014/main" id="{E7058B69-BEB8-324B-86E4-4983AC656F38}"/>
               </a:ext>
             </a:extLst>
           </p:cNvPr>
@@ -2227,7 +2254,7 @@
           <p:cNvPr id="3" name="Text Placeholder 2">
             <a:extLst>
               <a:ext uri="{FF2B5EF4-FFF2-40B4-BE49-F238E27FC236}">
-                <a16:creationId xmlns:a16="http://schemas.microsoft.com/office/drawing/2014/main" xmlns="" id="{235C959C-7E00-6344-A0B1-DAA9DF78CD42}"/>
+                <a16:creationId xmlns="" xmlns:a16="http://schemas.microsoft.com/office/drawing/2014/main" id="{235C959C-7E00-6344-A0B1-DAA9DF78CD42}"/>
               </a:ext>
             </a:extLst>
           </p:cNvPr>
@@ -2352,7 +2379,7 @@
           <p:cNvPr id="4" name="Date Placeholder 3">
             <a:extLst>
               <a:ext uri="{FF2B5EF4-FFF2-40B4-BE49-F238E27FC236}">
-                <a16:creationId xmlns:a16="http://schemas.microsoft.com/office/drawing/2014/main" xmlns="" id="{88BB7141-5064-E44F-809D-506124778058}"/>
+                <a16:creationId xmlns="" xmlns:a16="http://schemas.microsoft.com/office/drawing/2014/main" id="{88BB7141-5064-E44F-809D-506124778058}"/>
               </a:ext>
             </a:extLst>
           </p:cNvPr>
@@ -2370,7 +2397,7 @@
           <a:p>
             <a:fld id="{6BBF20CF-2588-EA45-96A5-9B2A2D83F5D1}" type="datetimeFigureOut">
               <a:rPr lang="en-US" smtClean="0"/>
-              <a:t>19/04/18</a:t>
+              <a:t>23/04/18</a:t>
             </a:fld>
             <a:endParaRPr lang="en-US"/>
           </a:p>
@@ -2381,7 +2408,7 @@
           <p:cNvPr id="5" name="Footer Placeholder 4">
             <a:extLst>
               <a:ext uri="{FF2B5EF4-FFF2-40B4-BE49-F238E27FC236}">
-                <a16:creationId xmlns:a16="http://schemas.microsoft.com/office/drawing/2014/main" xmlns="" id="{7CE8BD47-2E1C-D549-B849-A2426ACA5277}"/>
+                <a16:creationId xmlns="" xmlns:a16="http://schemas.microsoft.com/office/drawing/2014/main" id="{7CE8BD47-2E1C-D549-B849-A2426ACA5277}"/>
               </a:ext>
             </a:extLst>
           </p:cNvPr>
@@ -2406,7 +2433,7 @@
           <p:cNvPr id="6" name="Slide Number Placeholder 5">
             <a:extLst>
               <a:ext uri="{FF2B5EF4-FFF2-40B4-BE49-F238E27FC236}">
-                <a16:creationId xmlns:a16="http://schemas.microsoft.com/office/drawing/2014/main" xmlns="" id="{841472C8-B153-754C-9C6E-AE13EDC868B3}"/>
+                <a16:creationId xmlns="" xmlns:a16="http://schemas.microsoft.com/office/drawing/2014/main" id="{841472C8-B153-754C-9C6E-AE13EDC868B3}"/>
               </a:ext>
             </a:extLst>
           </p:cNvPr>
@@ -2465,7 +2492,7 @@
           <p:cNvPr id="2" name="Title 1">
             <a:extLst>
               <a:ext uri="{FF2B5EF4-FFF2-40B4-BE49-F238E27FC236}">
-                <a16:creationId xmlns:a16="http://schemas.microsoft.com/office/drawing/2014/main" xmlns="" id="{E6E2222B-574B-0A43-93D9-7A76C4DBAAC8}"/>
+                <a16:creationId xmlns="" xmlns:a16="http://schemas.microsoft.com/office/drawing/2014/main" id="{E6E2222B-574B-0A43-93D9-7A76C4DBAAC8}"/>
               </a:ext>
             </a:extLst>
           </p:cNvPr>
@@ -2493,7 +2520,7 @@
           <p:cNvPr id="3" name="Content Placeholder 2">
             <a:extLst>
               <a:ext uri="{FF2B5EF4-FFF2-40B4-BE49-F238E27FC236}">
-                <a16:creationId xmlns:a16="http://schemas.microsoft.com/office/drawing/2014/main" xmlns="" id="{C37815E7-563E-084E-B606-159C06943C91}"/>
+                <a16:creationId xmlns="" xmlns:a16="http://schemas.microsoft.com/office/drawing/2014/main" id="{C37815E7-563E-084E-B606-159C06943C91}"/>
               </a:ext>
             </a:extLst>
           </p:cNvPr>
@@ -2555,7 +2582,7 @@
           <p:cNvPr id="4" name="Content Placeholder 3">
             <a:extLst>
               <a:ext uri="{FF2B5EF4-FFF2-40B4-BE49-F238E27FC236}">
-                <a16:creationId xmlns:a16="http://schemas.microsoft.com/office/drawing/2014/main" xmlns="" id="{4247800E-0FD9-0447-A3FE-FA29DA62E769}"/>
+                <a16:creationId xmlns="" xmlns:a16="http://schemas.microsoft.com/office/drawing/2014/main" id="{4247800E-0FD9-0447-A3FE-FA29DA62E769}"/>
               </a:ext>
             </a:extLst>
           </p:cNvPr>
@@ -2617,7 +2644,7 @@
           <p:cNvPr id="5" name="Date Placeholder 4">
             <a:extLst>
               <a:ext uri="{FF2B5EF4-FFF2-40B4-BE49-F238E27FC236}">
-                <a16:creationId xmlns:a16="http://schemas.microsoft.com/office/drawing/2014/main" xmlns="" id="{F0148131-5496-2349-8070-6E2E2FFB32F8}"/>
+                <a16:creationId xmlns="" xmlns:a16="http://schemas.microsoft.com/office/drawing/2014/main" id="{F0148131-5496-2349-8070-6E2E2FFB32F8}"/>
               </a:ext>
             </a:extLst>
           </p:cNvPr>
@@ -2635,7 +2662,7 @@
           <a:p>
             <a:fld id="{6BBF20CF-2588-EA45-96A5-9B2A2D83F5D1}" type="datetimeFigureOut">
               <a:rPr lang="en-US" smtClean="0"/>
-              <a:t>19/04/18</a:t>
+              <a:t>23/04/18</a:t>
             </a:fld>
             <a:endParaRPr lang="en-US"/>
           </a:p>
@@ -2646,7 +2673,7 @@
           <p:cNvPr id="6" name="Footer Placeholder 5">
             <a:extLst>
               <a:ext uri="{FF2B5EF4-FFF2-40B4-BE49-F238E27FC236}">
-                <a16:creationId xmlns:a16="http://schemas.microsoft.com/office/drawing/2014/main" xmlns="" id="{01CA975E-C3F5-384C-B87C-6514226B1D19}"/>
+                <a16:creationId xmlns="" xmlns:a16="http://schemas.microsoft.com/office/drawing/2014/main" id="{01CA975E-C3F5-384C-B87C-6514226B1D19}"/>
               </a:ext>
             </a:extLst>
           </p:cNvPr>
@@ -2671,7 +2698,7 @@
           <p:cNvPr id="7" name="Slide Number Placeholder 6">
             <a:extLst>
               <a:ext uri="{FF2B5EF4-FFF2-40B4-BE49-F238E27FC236}">
-                <a16:creationId xmlns:a16="http://schemas.microsoft.com/office/drawing/2014/main" xmlns="" id="{1D8BD59C-B93E-6A4B-AF41-00A48E098C75}"/>
+                <a16:creationId xmlns="" xmlns:a16="http://schemas.microsoft.com/office/drawing/2014/main" id="{1D8BD59C-B93E-6A4B-AF41-00A48E098C75}"/>
               </a:ext>
             </a:extLst>
           </p:cNvPr>
@@ -2730,7 +2757,7 @@
           <p:cNvPr id="2" name="Title 1">
             <a:extLst>
               <a:ext uri="{FF2B5EF4-FFF2-40B4-BE49-F238E27FC236}">
-                <a16:creationId xmlns:a16="http://schemas.microsoft.com/office/drawing/2014/main" xmlns="" id="{62AA52A2-2D68-EF43-8EF1-C712F308C495}"/>
+                <a16:creationId xmlns="" xmlns:a16="http://schemas.microsoft.com/office/drawing/2014/main" id="{62AA52A2-2D68-EF43-8EF1-C712F308C495}"/>
               </a:ext>
             </a:extLst>
           </p:cNvPr>
@@ -2763,7 +2790,7 @@
           <p:cNvPr id="3" name="Text Placeholder 2">
             <a:extLst>
               <a:ext uri="{FF2B5EF4-FFF2-40B4-BE49-F238E27FC236}">
-                <a16:creationId xmlns:a16="http://schemas.microsoft.com/office/drawing/2014/main" xmlns="" id="{AAE0D99C-A376-3044-8D78-A0A4825462F6}"/>
+                <a16:creationId xmlns="" xmlns:a16="http://schemas.microsoft.com/office/drawing/2014/main" id="{AAE0D99C-A376-3044-8D78-A0A4825462F6}"/>
               </a:ext>
             </a:extLst>
           </p:cNvPr>
@@ -2834,7 +2861,7 @@
           <p:cNvPr id="4" name="Content Placeholder 3">
             <a:extLst>
               <a:ext uri="{FF2B5EF4-FFF2-40B4-BE49-F238E27FC236}">
-                <a16:creationId xmlns:a16="http://schemas.microsoft.com/office/drawing/2014/main" xmlns="" id="{19FE095E-6071-A942-9FB5-BC69DC31F5A3}"/>
+                <a16:creationId xmlns="" xmlns:a16="http://schemas.microsoft.com/office/drawing/2014/main" id="{19FE095E-6071-A942-9FB5-BC69DC31F5A3}"/>
               </a:ext>
             </a:extLst>
           </p:cNvPr>
@@ -2896,7 +2923,7 @@
           <p:cNvPr id="5" name="Text Placeholder 4">
             <a:extLst>
               <a:ext uri="{FF2B5EF4-FFF2-40B4-BE49-F238E27FC236}">
-                <a16:creationId xmlns:a16="http://schemas.microsoft.com/office/drawing/2014/main" xmlns="" id="{D8E2F3A4-4BAA-8041-90D2-77A2A2C27038}"/>
+                <a16:creationId xmlns="" xmlns:a16="http://schemas.microsoft.com/office/drawing/2014/main" id="{D8E2F3A4-4BAA-8041-90D2-77A2A2C27038}"/>
               </a:ext>
             </a:extLst>
           </p:cNvPr>
@@ -2967,7 +2994,7 @@
           <p:cNvPr id="6" name="Content Placeholder 5">
             <a:extLst>
               <a:ext uri="{FF2B5EF4-FFF2-40B4-BE49-F238E27FC236}">
-                <a16:creationId xmlns:a16="http://schemas.microsoft.com/office/drawing/2014/main" xmlns="" id="{1D7E8523-3979-7A49-A4FD-E584A5F1399E}"/>
+                <a16:creationId xmlns="" xmlns:a16="http://schemas.microsoft.com/office/drawing/2014/main" id="{1D7E8523-3979-7A49-A4FD-E584A5F1399E}"/>
               </a:ext>
             </a:extLst>
           </p:cNvPr>
@@ -3029,7 +3056,7 @@
           <p:cNvPr id="7" name="Date Placeholder 6">
             <a:extLst>
               <a:ext uri="{FF2B5EF4-FFF2-40B4-BE49-F238E27FC236}">
-                <a16:creationId xmlns:a16="http://schemas.microsoft.com/office/drawing/2014/main" xmlns="" id="{526E364E-4D34-7C43-9FE2-1862B7DF678C}"/>
+                <a16:creationId xmlns="" xmlns:a16="http://schemas.microsoft.com/office/drawing/2014/main" id="{526E364E-4D34-7C43-9FE2-1862B7DF678C}"/>
               </a:ext>
             </a:extLst>
           </p:cNvPr>
@@ -3047,7 +3074,7 @@
           <a:p>
             <a:fld id="{6BBF20CF-2588-EA45-96A5-9B2A2D83F5D1}" type="datetimeFigureOut">
               <a:rPr lang="en-US" smtClean="0"/>
-              <a:t>19/04/18</a:t>
+              <a:t>23/04/18</a:t>
             </a:fld>
             <a:endParaRPr lang="en-US"/>
           </a:p>
@@ -3058,7 +3085,7 @@
           <p:cNvPr id="8" name="Footer Placeholder 7">
             <a:extLst>
               <a:ext uri="{FF2B5EF4-FFF2-40B4-BE49-F238E27FC236}">
-                <a16:creationId xmlns:a16="http://schemas.microsoft.com/office/drawing/2014/main" xmlns="" id="{45EE3771-3D74-8C41-8A15-B555B7D94900}"/>
+                <a16:creationId xmlns="" xmlns:a16="http://schemas.microsoft.com/office/drawing/2014/main" id="{45EE3771-3D74-8C41-8A15-B555B7D94900}"/>
               </a:ext>
             </a:extLst>
           </p:cNvPr>
@@ -3083,7 +3110,7 @@
           <p:cNvPr id="9" name="Slide Number Placeholder 8">
             <a:extLst>
               <a:ext uri="{FF2B5EF4-FFF2-40B4-BE49-F238E27FC236}">
-                <a16:creationId xmlns:a16="http://schemas.microsoft.com/office/drawing/2014/main" xmlns="" id="{ED7F9722-7CD1-AF42-BDCB-1C1121A8F07A}"/>
+                <a16:creationId xmlns="" xmlns:a16="http://schemas.microsoft.com/office/drawing/2014/main" id="{ED7F9722-7CD1-AF42-BDCB-1C1121A8F07A}"/>
               </a:ext>
             </a:extLst>
           </p:cNvPr>
@@ -3142,7 +3169,7 @@
           <p:cNvPr id="2" name="Title 1">
             <a:extLst>
               <a:ext uri="{FF2B5EF4-FFF2-40B4-BE49-F238E27FC236}">
-                <a16:creationId xmlns:a16="http://schemas.microsoft.com/office/drawing/2014/main" xmlns="" id="{CB21EAF0-11A0-074B-A567-CECEC7179AE6}"/>
+                <a16:creationId xmlns="" xmlns:a16="http://schemas.microsoft.com/office/drawing/2014/main" id="{CB21EAF0-11A0-074B-A567-CECEC7179AE6}"/>
               </a:ext>
             </a:extLst>
           </p:cNvPr>
@@ -3170,7 +3197,7 @@
           <p:cNvPr id="3" name="Date Placeholder 2">
             <a:extLst>
               <a:ext uri="{FF2B5EF4-FFF2-40B4-BE49-F238E27FC236}">
-                <a16:creationId xmlns:a16="http://schemas.microsoft.com/office/drawing/2014/main" xmlns="" id="{DE4BD7B4-D6FD-7047-9884-9D7966653D24}"/>
+                <a16:creationId xmlns="" xmlns:a16="http://schemas.microsoft.com/office/drawing/2014/main" id="{DE4BD7B4-D6FD-7047-9884-9D7966653D24}"/>
               </a:ext>
             </a:extLst>
           </p:cNvPr>
@@ -3188,7 +3215,7 @@
           <a:p>
             <a:fld id="{6BBF20CF-2588-EA45-96A5-9B2A2D83F5D1}" type="datetimeFigureOut">
               <a:rPr lang="en-US" smtClean="0"/>
-              <a:t>19/04/18</a:t>
+              <a:t>23/04/18</a:t>
             </a:fld>
             <a:endParaRPr lang="en-US"/>
           </a:p>
@@ -3199,7 +3226,7 @@
           <p:cNvPr id="4" name="Footer Placeholder 3">
             <a:extLst>
               <a:ext uri="{FF2B5EF4-FFF2-40B4-BE49-F238E27FC236}">
-                <a16:creationId xmlns:a16="http://schemas.microsoft.com/office/drawing/2014/main" xmlns="" id="{251B80F8-131D-D045-B7F3-14F513520E9B}"/>
+                <a16:creationId xmlns="" xmlns:a16="http://schemas.microsoft.com/office/drawing/2014/main" id="{251B80F8-131D-D045-B7F3-14F513520E9B}"/>
               </a:ext>
             </a:extLst>
           </p:cNvPr>
@@ -3224,7 +3251,7 @@
           <p:cNvPr id="5" name="Slide Number Placeholder 4">
             <a:extLst>
               <a:ext uri="{FF2B5EF4-FFF2-40B4-BE49-F238E27FC236}">
-                <a16:creationId xmlns:a16="http://schemas.microsoft.com/office/drawing/2014/main" xmlns="" id="{296C4884-67CE-1345-B0F9-AF331CBC2AAA}"/>
+                <a16:creationId xmlns="" xmlns:a16="http://schemas.microsoft.com/office/drawing/2014/main" id="{296C4884-67CE-1345-B0F9-AF331CBC2AAA}"/>
               </a:ext>
             </a:extLst>
           </p:cNvPr>
@@ -3283,7 +3310,7 @@
           <p:cNvPr id="2" name="Date Placeholder 1">
             <a:extLst>
               <a:ext uri="{FF2B5EF4-FFF2-40B4-BE49-F238E27FC236}">
-                <a16:creationId xmlns:a16="http://schemas.microsoft.com/office/drawing/2014/main" xmlns="" id="{9F9B9B4C-AA6F-9D40-886D-C9AE3D5BC9C8}"/>
+                <a16:creationId xmlns="" xmlns:a16="http://schemas.microsoft.com/office/drawing/2014/main" id="{9F9B9B4C-AA6F-9D40-886D-C9AE3D5BC9C8}"/>
               </a:ext>
             </a:extLst>
           </p:cNvPr>
@@ -3301,7 +3328,7 @@
           <a:p>
             <a:fld id="{6BBF20CF-2588-EA45-96A5-9B2A2D83F5D1}" type="datetimeFigureOut">
               <a:rPr lang="en-US" smtClean="0"/>
-              <a:t>19/04/18</a:t>
+              <a:t>23/04/18</a:t>
             </a:fld>
             <a:endParaRPr lang="en-US"/>
           </a:p>
@@ -3312,7 +3339,7 @@
           <p:cNvPr id="3" name="Footer Placeholder 2">
             <a:extLst>
               <a:ext uri="{FF2B5EF4-FFF2-40B4-BE49-F238E27FC236}">
-                <a16:creationId xmlns:a16="http://schemas.microsoft.com/office/drawing/2014/main" xmlns="" id="{6E284E22-4941-AF4C-BE99-894FDB414FE7}"/>
+                <a16:creationId xmlns="" xmlns:a16="http://schemas.microsoft.com/office/drawing/2014/main" id="{6E284E22-4941-AF4C-BE99-894FDB414FE7}"/>
               </a:ext>
             </a:extLst>
           </p:cNvPr>
@@ -3337,7 +3364,7 @@
           <p:cNvPr id="4" name="Slide Number Placeholder 3">
             <a:extLst>
               <a:ext uri="{FF2B5EF4-FFF2-40B4-BE49-F238E27FC236}">
-                <a16:creationId xmlns:a16="http://schemas.microsoft.com/office/drawing/2014/main" xmlns="" id="{67259881-295C-7145-A0C4-28574035D00C}"/>
+                <a16:creationId xmlns="" xmlns:a16="http://schemas.microsoft.com/office/drawing/2014/main" id="{67259881-295C-7145-A0C4-28574035D00C}"/>
               </a:ext>
             </a:extLst>
           </p:cNvPr>
@@ -3396,7 +3423,7 @@
           <p:cNvPr id="2" name="Title 1">
             <a:extLst>
               <a:ext uri="{FF2B5EF4-FFF2-40B4-BE49-F238E27FC236}">
-                <a16:creationId xmlns:a16="http://schemas.microsoft.com/office/drawing/2014/main" xmlns="" id="{54253EB3-7BDC-0C40-9317-980F89B003FB}"/>
+                <a16:creationId xmlns="" xmlns:a16="http://schemas.microsoft.com/office/drawing/2014/main" id="{54253EB3-7BDC-0C40-9317-980F89B003FB}"/>
               </a:ext>
             </a:extLst>
           </p:cNvPr>
@@ -3433,7 +3460,7 @@
           <p:cNvPr id="3" name="Content Placeholder 2">
             <a:extLst>
               <a:ext uri="{FF2B5EF4-FFF2-40B4-BE49-F238E27FC236}">
-                <a16:creationId xmlns:a16="http://schemas.microsoft.com/office/drawing/2014/main" xmlns="" id="{FBCD4F8F-99F4-3A48-BA0B-6BB00EF538F4}"/>
+                <a16:creationId xmlns="" xmlns:a16="http://schemas.microsoft.com/office/drawing/2014/main" id="{FBCD4F8F-99F4-3A48-BA0B-6BB00EF538F4}"/>
               </a:ext>
             </a:extLst>
           </p:cNvPr>
@@ -3523,7 +3550,7 @@
           <p:cNvPr id="4" name="Text Placeholder 3">
             <a:extLst>
               <a:ext uri="{FF2B5EF4-FFF2-40B4-BE49-F238E27FC236}">
-                <a16:creationId xmlns:a16="http://schemas.microsoft.com/office/drawing/2014/main" xmlns="" id="{F2AE23DF-5DB5-444A-916E-5FCD214AC438}"/>
+                <a16:creationId xmlns="" xmlns:a16="http://schemas.microsoft.com/office/drawing/2014/main" id="{F2AE23DF-5DB5-444A-916E-5FCD214AC438}"/>
               </a:ext>
             </a:extLst>
           </p:cNvPr>
@@ -3594,7 +3621,7 @@
           <p:cNvPr id="5" name="Date Placeholder 4">
             <a:extLst>
               <a:ext uri="{FF2B5EF4-FFF2-40B4-BE49-F238E27FC236}">
-                <a16:creationId xmlns:a16="http://schemas.microsoft.com/office/drawing/2014/main" xmlns="" id="{157E067E-2DE9-3847-810E-F1195B3D1064}"/>
+                <a16:creationId xmlns="" xmlns:a16="http://schemas.microsoft.com/office/drawing/2014/main" id="{157E067E-2DE9-3847-810E-F1195B3D1064}"/>
               </a:ext>
             </a:extLst>
           </p:cNvPr>
@@ -3612,7 +3639,7 @@
           <a:p>
             <a:fld id="{6BBF20CF-2588-EA45-96A5-9B2A2D83F5D1}" type="datetimeFigureOut">
               <a:rPr lang="en-US" smtClean="0"/>
-              <a:t>19/04/18</a:t>
+              <a:t>23/04/18</a:t>
             </a:fld>
             <a:endParaRPr lang="en-US"/>
           </a:p>
@@ -3623,7 +3650,7 @@
           <p:cNvPr id="6" name="Footer Placeholder 5">
             <a:extLst>
               <a:ext uri="{FF2B5EF4-FFF2-40B4-BE49-F238E27FC236}">
-                <a16:creationId xmlns:a16="http://schemas.microsoft.com/office/drawing/2014/main" xmlns="" id="{CD186560-5E09-6B46-99DC-FAEA21225102}"/>
+                <a16:creationId xmlns="" xmlns:a16="http://schemas.microsoft.com/office/drawing/2014/main" id="{CD186560-5E09-6B46-99DC-FAEA21225102}"/>
               </a:ext>
             </a:extLst>
           </p:cNvPr>
@@ -3648,7 +3675,7 @@
           <p:cNvPr id="7" name="Slide Number Placeholder 6">
             <a:extLst>
               <a:ext uri="{FF2B5EF4-FFF2-40B4-BE49-F238E27FC236}">
-                <a16:creationId xmlns:a16="http://schemas.microsoft.com/office/drawing/2014/main" xmlns="" id="{C1335311-EA11-AA4A-B604-E8DF38B70916}"/>
+                <a16:creationId xmlns="" xmlns:a16="http://schemas.microsoft.com/office/drawing/2014/main" id="{C1335311-EA11-AA4A-B604-E8DF38B70916}"/>
               </a:ext>
             </a:extLst>
           </p:cNvPr>
@@ -3707,7 +3734,7 @@
           <p:cNvPr id="2" name="Title 1">
             <a:extLst>
               <a:ext uri="{FF2B5EF4-FFF2-40B4-BE49-F238E27FC236}">
-                <a16:creationId xmlns:a16="http://schemas.microsoft.com/office/drawing/2014/main" xmlns="" id="{36195AA7-561F-3041-AFFC-B14307E22DB8}"/>
+                <a16:creationId xmlns="" xmlns:a16="http://schemas.microsoft.com/office/drawing/2014/main" id="{36195AA7-561F-3041-AFFC-B14307E22DB8}"/>
               </a:ext>
             </a:extLst>
           </p:cNvPr>
@@ -3744,7 +3771,7 @@
           <p:cNvPr id="3" name="Picture Placeholder 2">
             <a:extLst>
               <a:ext uri="{FF2B5EF4-FFF2-40B4-BE49-F238E27FC236}">
-                <a16:creationId xmlns:a16="http://schemas.microsoft.com/office/drawing/2014/main" xmlns="" id="{98885482-AAE1-9342-9F66-F195D3DD76EA}"/>
+                <a16:creationId xmlns="" xmlns:a16="http://schemas.microsoft.com/office/drawing/2014/main" id="{98885482-AAE1-9342-9F66-F195D3DD76EA}"/>
               </a:ext>
             </a:extLst>
           </p:cNvPr>
@@ -3811,7 +3838,7 @@
           <p:cNvPr id="4" name="Text Placeholder 3">
             <a:extLst>
               <a:ext uri="{FF2B5EF4-FFF2-40B4-BE49-F238E27FC236}">
-                <a16:creationId xmlns:a16="http://schemas.microsoft.com/office/drawing/2014/main" xmlns="" id="{6F06BE98-8C88-D641-AC7A-DB6D1C287457}"/>
+                <a16:creationId xmlns="" xmlns:a16="http://schemas.microsoft.com/office/drawing/2014/main" id="{6F06BE98-8C88-D641-AC7A-DB6D1C287457}"/>
               </a:ext>
             </a:extLst>
           </p:cNvPr>
@@ -3882,7 +3909,7 @@
           <p:cNvPr id="5" name="Date Placeholder 4">
             <a:extLst>
               <a:ext uri="{FF2B5EF4-FFF2-40B4-BE49-F238E27FC236}">
-                <a16:creationId xmlns:a16="http://schemas.microsoft.com/office/drawing/2014/main" xmlns="" id="{90530A47-790A-FA4B-94CF-34646F74E84F}"/>
+                <a16:creationId xmlns="" xmlns:a16="http://schemas.microsoft.com/office/drawing/2014/main" id="{90530A47-790A-FA4B-94CF-34646F74E84F}"/>
               </a:ext>
             </a:extLst>
           </p:cNvPr>
@@ -3900,7 +3927,7 @@
           <a:p>
             <a:fld id="{6BBF20CF-2588-EA45-96A5-9B2A2D83F5D1}" type="datetimeFigureOut">
               <a:rPr lang="en-US" smtClean="0"/>
-              <a:t>19/04/18</a:t>
+              <a:t>23/04/18</a:t>
             </a:fld>
             <a:endParaRPr lang="en-US"/>
           </a:p>
@@ -3911,7 +3938,7 @@
           <p:cNvPr id="6" name="Footer Placeholder 5">
             <a:extLst>
               <a:ext uri="{FF2B5EF4-FFF2-40B4-BE49-F238E27FC236}">
-                <a16:creationId xmlns:a16="http://schemas.microsoft.com/office/drawing/2014/main" xmlns="" id="{902C4A54-EDFC-BC47-93EC-15AE7714D97C}"/>
+                <a16:creationId xmlns="" xmlns:a16="http://schemas.microsoft.com/office/drawing/2014/main" id="{902C4A54-EDFC-BC47-93EC-15AE7714D97C}"/>
               </a:ext>
             </a:extLst>
           </p:cNvPr>
@@ -3936,7 +3963,7 @@
           <p:cNvPr id="7" name="Slide Number Placeholder 6">
             <a:extLst>
               <a:ext uri="{FF2B5EF4-FFF2-40B4-BE49-F238E27FC236}">
-                <a16:creationId xmlns:a16="http://schemas.microsoft.com/office/drawing/2014/main" xmlns="" id="{BBA8007D-9739-6B4C-9ABC-6A4755A84869}"/>
+                <a16:creationId xmlns="" xmlns:a16="http://schemas.microsoft.com/office/drawing/2014/main" id="{BBA8007D-9739-6B4C-9ABC-6A4755A84869}"/>
               </a:ext>
             </a:extLst>
           </p:cNvPr>
@@ -4000,7 +4027,7 @@
           <p:cNvPr id="2" name="Title Placeholder 1">
             <a:extLst>
               <a:ext uri="{FF2B5EF4-FFF2-40B4-BE49-F238E27FC236}">
-                <a16:creationId xmlns:a16="http://schemas.microsoft.com/office/drawing/2014/main" xmlns="" id="{DFFF00DF-EE10-D147-AC0D-53088C6FE37D}"/>
+                <a16:creationId xmlns="" xmlns:a16="http://schemas.microsoft.com/office/drawing/2014/main" id="{DFFF00DF-EE10-D147-AC0D-53088C6FE37D}"/>
               </a:ext>
             </a:extLst>
           </p:cNvPr>
@@ -4038,7 +4065,7 @@
           <p:cNvPr id="3" name="Text Placeholder 2">
             <a:extLst>
               <a:ext uri="{FF2B5EF4-FFF2-40B4-BE49-F238E27FC236}">
-                <a16:creationId xmlns:a16="http://schemas.microsoft.com/office/drawing/2014/main" xmlns="" id="{04FF84B8-03F1-DA4A-9654-D5C6543CC946}"/>
+                <a16:creationId xmlns="" xmlns:a16="http://schemas.microsoft.com/office/drawing/2014/main" id="{04FF84B8-03F1-DA4A-9654-D5C6543CC946}"/>
               </a:ext>
             </a:extLst>
           </p:cNvPr>
@@ -4105,7 +4132,7 @@
           <p:cNvPr id="4" name="Date Placeholder 3">
             <a:extLst>
               <a:ext uri="{FF2B5EF4-FFF2-40B4-BE49-F238E27FC236}">
-                <a16:creationId xmlns:a16="http://schemas.microsoft.com/office/drawing/2014/main" xmlns="" id="{2C99DAAF-19A1-C044-9C82-D41084F280F8}"/>
+                <a16:creationId xmlns="" xmlns:a16="http://schemas.microsoft.com/office/drawing/2014/main" id="{2C99DAAF-19A1-C044-9C82-D41084F280F8}"/>
               </a:ext>
             </a:extLst>
           </p:cNvPr>
@@ -4141,7 +4168,7 @@
           <a:p>
             <a:fld id="{6BBF20CF-2588-EA45-96A5-9B2A2D83F5D1}" type="datetimeFigureOut">
               <a:rPr lang="en-US" smtClean="0"/>
-              <a:t>19/04/18</a:t>
+              <a:t>23/04/18</a:t>
             </a:fld>
             <a:endParaRPr lang="en-US"/>
           </a:p>
@@ -4152,7 +4179,7 @@
           <p:cNvPr id="5" name="Footer Placeholder 4">
             <a:extLst>
               <a:ext uri="{FF2B5EF4-FFF2-40B4-BE49-F238E27FC236}">
-                <a16:creationId xmlns:a16="http://schemas.microsoft.com/office/drawing/2014/main" xmlns="" id="{959F16B9-9D54-8B4B-B39A-003AF9574BDC}"/>
+                <a16:creationId xmlns="" xmlns:a16="http://schemas.microsoft.com/office/drawing/2014/main" id="{959F16B9-9D54-8B4B-B39A-003AF9574BDC}"/>
               </a:ext>
             </a:extLst>
           </p:cNvPr>
@@ -4195,7 +4222,7 @@
           <p:cNvPr id="6" name="Slide Number Placeholder 5">
             <a:extLst>
               <a:ext uri="{FF2B5EF4-FFF2-40B4-BE49-F238E27FC236}">
-                <a16:creationId xmlns:a16="http://schemas.microsoft.com/office/drawing/2014/main" xmlns="" id="{A20BEDDC-546D-DF4D-8E2D-A7AF285D02D9}"/>
+                <a16:creationId xmlns="" xmlns:a16="http://schemas.microsoft.com/office/drawing/2014/main" id="{A20BEDDC-546D-DF4D-8E2D-A7AF285D02D9}"/>
               </a:ext>
             </a:extLst>
           </p:cNvPr>
@@ -4563,7 +4590,7 @@
           <p:cNvPr id="4" name="TextBox 3">
             <a:extLst>
               <a:ext uri="{FF2B5EF4-FFF2-40B4-BE49-F238E27FC236}">
-                <a16:creationId xmlns:a16="http://schemas.microsoft.com/office/drawing/2014/main" xmlns="" id="{443C09B0-55B8-0C49-B33C-09C8A2FC6F36}"/>
+                <a16:creationId xmlns="" xmlns:a16="http://schemas.microsoft.com/office/drawing/2014/main" id="{443C09B0-55B8-0C49-B33C-09C8A2FC6F36}"/>
               </a:ext>
             </a:extLst>
           </p:cNvPr>
@@ -4641,7 +4668,7 @@
           <p:cNvPr id="5" name="TextBox 4">
             <a:extLst>
               <a:ext uri="{FF2B5EF4-FFF2-40B4-BE49-F238E27FC236}">
-                <a16:creationId xmlns:a16="http://schemas.microsoft.com/office/drawing/2014/main" xmlns="" id="{FA457497-166F-C84C-8280-AD0D7503B721}"/>
+                <a16:creationId xmlns="" xmlns:a16="http://schemas.microsoft.com/office/drawing/2014/main" id="{FA457497-166F-C84C-8280-AD0D7503B721}"/>
               </a:ext>
             </a:extLst>
           </p:cNvPr>
@@ -4811,7 +4838,7 @@
           <p:cNvPr id="9" name="TextBox 8">
             <a:extLst>
               <a:ext uri="{FF2B5EF4-FFF2-40B4-BE49-F238E27FC236}">
-                <a16:creationId xmlns:a16="http://schemas.microsoft.com/office/drawing/2014/main" xmlns="" id="{78FD756D-EED2-7642-A1E4-6B9A34A14EF6}"/>
+                <a16:creationId xmlns="" xmlns:a16="http://schemas.microsoft.com/office/drawing/2014/main" id="{78FD756D-EED2-7642-A1E4-6B9A34A14EF6}"/>
               </a:ext>
             </a:extLst>
           </p:cNvPr>
@@ -4867,7 +4894,7 @@
           <p:cNvPr id="10" name="TextBox 9">
             <a:extLst>
               <a:ext uri="{FF2B5EF4-FFF2-40B4-BE49-F238E27FC236}">
-                <a16:creationId xmlns:a16="http://schemas.microsoft.com/office/drawing/2014/main" xmlns="" id="{A8A101B5-C5D4-B84B-BD70-19FB4997C036}"/>
+                <a16:creationId xmlns="" xmlns:a16="http://schemas.microsoft.com/office/drawing/2014/main" id="{A8A101B5-C5D4-B84B-BD70-19FB4997C036}"/>
               </a:ext>
             </a:extLst>
           </p:cNvPr>
@@ -4995,7 +5022,7 @@
           <p:cNvPr id="11" name="TextBox 10">
             <a:extLst>
               <a:ext uri="{FF2B5EF4-FFF2-40B4-BE49-F238E27FC236}">
-                <a16:creationId xmlns:a16="http://schemas.microsoft.com/office/drawing/2014/main" xmlns="" id="{43C6BEDE-81DA-1243-B056-663EF99A20D9}"/>
+                <a16:creationId xmlns="" xmlns:a16="http://schemas.microsoft.com/office/drawing/2014/main" id="{43C6BEDE-81DA-1243-B056-663EF99A20D9}"/>
               </a:ext>
             </a:extLst>
           </p:cNvPr>
@@ -5076,7 +5103,7 @@
           <p:cNvPr id="12" name="TextBox 11">
             <a:extLst>
               <a:ext uri="{FF2B5EF4-FFF2-40B4-BE49-F238E27FC236}">
-                <a16:creationId xmlns:a16="http://schemas.microsoft.com/office/drawing/2014/main" xmlns="" id="{98D40128-9724-D848-92EB-D7CA030E2A2D}"/>
+                <a16:creationId xmlns="" xmlns:a16="http://schemas.microsoft.com/office/drawing/2014/main" id="{98D40128-9724-D848-92EB-D7CA030E2A2D}"/>
               </a:ext>
             </a:extLst>
           </p:cNvPr>
@@ -5159,7 +5186,7 @@
           <p:cNvPr id="13" name="TextBox 12">
             <a:extLst>
               <a:ext uri="{FF2B5EF4-FFF2-40B4-BE49-F238E27FC236}">
-                <a16:creationId xmlns:a16="http://schemas.microsoft.com/office/drawing/2014/main" xmlns="" id="{B857AF8C-95A4-B94A-A664-CACB4051BB7E}"/>
+                <a16:creationId xmlns="" xmlns:a16="http://schemas.microsoft.com/office/drawing/2014/main" id="{B857AF8C-95A4-B94A-A664-CACB4051BB7E}"/>
               </a:ext>
             </a:extLst>
           </p:cNvPr>
@@ -5269,7 +5296,7 @@
           <p:cNvPr id="14" name="TextBox 13">
             <a:extLst>
               <a:ext uri="{FF2B5EF4-FFF2-40B4-BE49-F238E27FC236}">
-                <a16:creationId xmlns:a16="http://schemas.microsoft.com/office/drawing/2014/main" xmlns="" id="{80044490-F023-C449-82C4-D981D014E4AA}"/>
+                <a16:creationId xmlns="" xmlns:a16="http://schemas.microsoft.com/office/drawing/2014/main" id="{80044490-F023-C449-82C4-D981D014E4AA}"/>
               </a:ext>
             </a:extLst>
           </p:cNvPr>
@@ -5379,7 +5406,7 @@
           <p:cNvPr id="15" name="TextBox 14">
             <a:extLst>
               <a:ext uri="{FF2B5EF4-FFF2-40B4-BE49-F238E27FC236}">
-                <a16:creationId xmlns:a16="http://schemas.microsoft.com/office/drawing/2014/main" xmlns="" id="{92B8F2CB-6F45-994B-AF6C-D90DC9A06FE0}"/>
+                <a16:creationId xmlns="" xmlns:a16="http://schemas.microsoft.com/office/drawing/2014/main" id="{92B8F2CB-6F45-994B-AF6C-D90DC9A06FE0}"/>
               </a:ext>
             </a:extLst>
           </p:cNvPr>
@@ -5428,7 +5455,7 @@
           <p:cNvPr id="17" name="Elbow Connector 16">
             <a:extLst>
               <a:ext uri="{FF2B5EF4-FFF2-40B4-BE49-F238E27FC236}">
-                <a16:creationId xmlns:a16="http://schemas.microsoft.com/office/drawing/2014/main" xmlns="" id="{B8451113-F337-294B-A45C-A6851347EE25}"/>
+                <a16:creationId xmlns="" xmlns:a16="http://schemas.microsoft.com/office/drawing/2014/main" id="{B8451113-F337-294B-A45C-A6851347EE25}"/>
               </a:ext>
             </a:extLst>
           </p:cNvPr>
@@ -5474,7 +5501,7 @@
           <p:cNvPr id="6" name="TextBox 5">
             <a:extLst>
               <a:ext uri="{FF2B5EF4-FFF2-40B4-BE49-F238E27FC236}">
-                <a16:creationId xmlns:a16="http://schemas.microsoft.com/office/drawing/2014/main" xmlns="" id="{D850E8BC-B2D6-F54F-8D21-789F4BDD690F}"/>
+                <a16:creationId xmlns="" xmlns:a16="http://schemas.microsoft.com/office/drawing/2014/main" id="{D850E8BC-B2D6-F54F-8D21-789F4BDD690F}"/>
               </a:ext>
             </a:extLst>
           </p:cNvPr>
@@ -5575,7 +5602,7 @@
           <p:cNvPr id="7" name="TextBox 6">
             <a:extLst>
               <a:ext uri="{FF2B5EF4-FFF2-40B4-BE49-F238E27FC236}">
-                <a16:creationId xmlns:a16="http://schemas.microsoft.com/office/drawing/2014/main" xmlns="" id="{8A88C321-2161-294F-AF69-08959D5F3E4D}"/>
+                <a16:creationId xmlns="" xmlns:a16="http://schemas.microsoft.com/office/drawing/2014/main" id="{8A88C321-2161-294F-AF69-08959D5F3E4D}"/>
               </a:ext>
             </a:extLst>
           </p:cNvPr>
@@ -5718,7 +5745,7 @@
           <p:cNvPr id="8" name="TextBox 7">
             <a:extLst>
               <a:ext uri="{FF2B5EF4-FFF2-40B4-BE49-F238E27FC236}">
-                <a16:creationId xmlns:a16="http://schemas.microsoft.com/office/drawing/2014/main" xmlns="" id="{36AAF7F2-9D19-3640-B651-CA6AB1E0D45F}"/>
+                <a16:creationId xmlns="" xmlns:a16="http://schemas.microsoft.com/office/drawing/2014/main" id="{36AAF7F2-9D19-3640-B651-CA6AB1E0D45F}"/>
               </a:ext>
             </a:extLst>
           </p:cNvPr>
@@ -5817,7 +5844,7 @@
           <p:cNvPr id="16" name="TextBox 15">
             <a:extLst>
               <a:ext uri="{FF2B5EF4-FFF2-40B4-BE49-F238E27FC236}">
-                <a16:creationId xmlns:a16="http://schemas.microsoft.com/office/drawing/2014/main" xmlns="" id="{8A88C321-2161-294F-AF69-08959D5F3E4D}"/>
+                <a16:creationId xmlns="" xmlns:a16="http://schemas.microsoft.com/office/drawing/2014/main" id="{8A88C321-2161-294F-AF69-08959D5F3E4D}"/>
               </a:ext>
             </a:extLst>
           </p:cNvPr>
@@ -5899,7 +5926,7 @@
           <p:cNvPr id="18" name="TextBox 17">
             <a:extLst>
               <a:ext uri="{FF2B5EF4-FFF2-40B4-BE49-F238E27FC236}">
-                <a16:creationId xmlns:a16="http://schemas.microsoft.com/office/drawing/2014/main" xmlns="" id="{92B8F2CB-6F45-994B-AF6C-D90DC9A06FE0}"/>
+                <a16:creationId xmlns="" xmlns:a16="http://schemas.microsoft.com/office/drawing/2014/main" id="{92B8F2CB-6F45-994B-AF6C-D90DC9A06FE0}"/>
               </a:ext>
             </a:extLst>
           </p:cNvPr>
@@ -5963,7 +5990,7 @@
           <p:cNvPr id="19" name="TextBox 18">
             <a:extLst>
               <a:ext uri="{FF2B5EF4-FFF2-40B4-BE49-F238E27FC236}">
-                <a16:creationId xmlns:a16="http://schemas.microsoft.com/office/drawing/2014/main" xmlns="" id="{92B8F2CB-6F45-994B-AF6C-D90DC9A06FE0}"/>
+                <a16:creationId xmlns="" xmlns:a16="http://schemas.microsoft.com/office/drawing/2014/main" id="{92B8F2CB-6F45-994B-AF6C-D90DC9A06FE0}"/>
               </a:ext>
             </a:extLst>
           </p:cNvPr>
@@ -6073,7 +6100,7 @@
           <p:cNvPr id="20" name="TextBox 19">
             <a:extLst>
               <a:ext uri="{FF2B5EF4-FFF2-40B4-BE49-F238E27FC236}">
-                <a16:creationId xmlns:a16="http://schemas.microsoft.com/office/drawing/2014/main" xmlns="" id="{92B8F2CB-6F45-994B-AF6C-D90DC9A06FE0}"/>
+                <a16:creationId xmlns="" xmlns:a16="http://schemas.microsoft.com/office/drawing/2014/main" id="{92B8F2CB-6F45-994B-AF6C-D90DC9A06FE0}"/>
               </a:ext>
             </a:extLst>
           </p:cNvPr>
@@ -7929,14 +7956,42 @@
                 <a:latin typeface="Arial"/>
                 <a:cs typeface="Arial"/>
               </a:rPr>
-              <a:t>Read_COORD</a:t>
+              <a:t>ReadCOORD</a:t>
             </a:r>
             <a:r>
               <a:rPr lang="en-US" sz="1400" i="1" dirty="0" smtClean="0">
                 <a:latin typeface="Arial"/>
                 <a:cs typeface="Arial"/>
               </a:rPr>
-              <a:t> etc.  – stuffing the data into different objects.</a:t>
+              <a:t> (</a:t>
+            </a:r>
+            <a:r>
+              <a:rPr lang="en-US" sz="1400" i="1" dirty="0" err="1" smtClean="0">
+                <a:latin typeface="Arial"/>
+                <a:cs typeface="Arial"/>
+              </a:rPr>
+              <a:t>initialises</a:t>
+            </a:r>
+            <a:r>
+              <a:rPr lang="en-US" sz="1400" i="1" dirty="0" smtClean="0">
+                <a:latin typeface="Arial"/>
+                <a:cs typeface="Arial"/>
+              </a:rPr>
+              <a:t> the pillars) – </a:t>
+            </a:r>
+            <a:r>
+              <a:rPr lang="en-US" sz="1400" i="1" dirty="0" err="1" smtClean="0">
+                <a:latin typeface="Arial"/>
+                <a:cs typeface="Arial"/>
+              </a:rPr>
+              <a:t>ReadZCORN</a:t>
+            </a:r>
+            <a:r>
+              <a:rPr lang="en-US" sz="1400" i="1" dirty="0" smtClean="0">
+                <a:latin typeface="Arial"/>
+                <a:cs typeface="Arial"/>
+              </a:rPr>
+              <a:t> (subdivides the pillars by the cell corners, creating the beads).</a:t>
             </a:r>
           </a:p>
           <a:p>
@@ -8315,7 +8370,7 @@
   <a:extraClrSchemeLst/>
   <a:extLst>
     <a:ext uri="{05A4C25C-085E-4340-85A3-A5531E510DB2}">
-      <thm15:themeFamily xmlns:thm15="http://schemas.microsoft.com/office/thememl/2012/main" xmlns="" name="Office Theme" id="{62F939B6-93AF-4DB8-9C6B-D6C7DFDC589F}" vid="{4A3C46E8-61CC-4603-A589-7422A47A8E4A}"/>
+      <thm15:themeFamily xmlns="" xmlns:thm15="http://schemas.microsoft.com/office/thememl/2012/main" name="Office Theme" id="{62F939B6-93AF-4DB8-9C6B-D6C7DFDC589F}" vid="{4A3C46E8-61CC-4603-A589-7422A47A8E4A}"/>
     </a:ext>
   </a:extLst>
 </a:theme>
@@ -8610,7 +8665,7 @@
   <a:extraClrSchemeLst/>
   <a:extLst>
     <a:ext uri="{05A4C25C-085E-4340-85A3-A5531E510DB2}">
-      <thm15:themeFamily xmlns:thm15="http://schemas.microsoft.com/office/thememl/2012/main" xmlns="" name="Office Theme" id="{62F939B6-93AF-4DB8-9C6B-D6C7DFDC589F}" vid="{4A3C46E8-61CC-4603-A589-7422A47A8E4A}"/>
+      <thm15:themeFamily xmlns="" xmlns:thm15="http://schemas.microsoft.com/office/thememl/2012/main" name="Office Theme" id="{62F939B6-93AF-4DB8-9C6B-D6C7DFDC589F}" vid="{4A3C46E8-61CC-4603-A589-7422A47A8E4A}"/>
     </a:ext>
   </a:extLst>
 </a:theme>

</xml_diff>